<commit_message>
Restore the copyright line in Level 1 Lesson 1 and add it to the deck credits
- Level1_Lesson1.md: credits line back to 'Course materials: © 2026 the authors, CC BY-NC-SA 4.0.'
- Level1_Lesson1_Slides.pptx: credits slide (slide 23) gets the Level 2 deck line
  '© 2026 the authors. The authors license this deck under CC BY-NC-SA 4.0.'; the Twemoji
  CC BY 4.0 credit is unchanged
- Rebuilt the PDF/DOCX (build.sh 1 --publish), the presenter data (export_deck.py --level 1)
  and src/content_level1.json (download sizes)
</commit_message>
<xml_diff>
--- a/level1/slides/Level1_Lesson1_Slides.pptx
+++ b/level1/slides/Level1_Lesson1_Slides.pptx
@@ -12893,6 +12893,26 @@
                 <a:cs typeface="Lexend Deca" pitchFamily="34" charset="-120"/>
               </a:rPr>
               <a:t>Audio: synthetic voices made with Chatterbox TTS (MIT License); each file carries an inaudible Perth watermark marking it as AI-generated. Font: Lexend Deca (OFL 1.1).</a:t>
+            </a:r>
+            <a:endParaRPr lang="en-US" sz="2200" dirty="0"/>
+          </a:p>
+          <a:p>
+            <a:pPr algn="l" indent="0" marL="0">
+              <a:spcAft>
+                <a:spcPts val="600"/>
+              </a:spcAft>
+              <a:buNone/>
+            </a:pPr>
+            <a:r>
+              <a:rPr lang="en-US" sz="1600" dirty="0" b="0">
+                <a:solidFill>
+                  <a:srgbClr val="1B2236"/>
+                </a:solidFill>
+                <a:latin typeface="Lexend Deca" pitchFamily="34" charset="0"/>
+                <a:ea typeface="Lexend Deca" pitchFamily="34" charset="-122"/>
+                <a:cs typeface="Lexend Deca" pitchFamily="34" charset="-120"/>
+              </a:rPr>
+              <a:t>© 2026 the authors. The authors license this deck under CC BY-NC-SA 4.0.</a:t>
             </a:r>
             <a:endParaRPr lang="en-US" sz="2200" dirty="0"/>
           </a:p>

</xml_diff>

<commit_message>
Level 1 Lesson 1 slides: remove the task instruction icons
Slide 4 (How Our Class Works) is now a plain list of five equal rows; the
click animations are kept. Remove the icon cells on slides 8, 11 and 15 and
the icons in front of instructions on the other slides. Update the speaker
notes and the credits line. Regenerate the presenter data.
</commit_message>
<xml_diff>
--- a/level1/slides/Level1_Lesson1_Slides.pptx
+++ b/level1/slides/Level1_Lesson1_Slides.pptx
@@ -1034,7 +1034,7 @@
           <a:p>
             <a:r>
               <a:rPr lang="en-US" dirty="0"/>
-              <a:t>Say: "Listen again. Circle the letters." Point to the ⭕ icon. R (Ana) and A (Carlos) are already there.</a:t>
+              <a:t>Say: "Listen again. Circle the letters." R (Ana) and A (Carlos) are already there.</a:t>
             </a:r>
           </a:p>
           <a:p>
@@ -1310,7 +1310,7 @@
           <a:p>
             <a:r>
               <a:rPr lang="en-US" dirty="0"/>
-              <a:t>Homework (10 minutes): open the Homework page. Do item 1 together. Point to each icon so learners know what to do at home.</a:t>
+              <a:t>Homework (10 minutes): open the Homework page. Do item 1 together. Point to each instruction so learners know what to do at home.</a:t>
             </a:r>
           </a:p>
           <a:p>
@@ -1820,7 +1820,7 @@
           <a:p>
             <a:r>
               <a:rPr lang="en-US" dirty="0"/>
-              <a:t>Show the icons: 👥 partner, ☝️ point, 🗣️ say.</a:t>
+              <a:t>Show it: point to two people ("Partner"), point to a picture ("Point"), and say the word ("Say").</a:t>
             </a:r>
           </a:p>
           <a:p>
@@ -2171,13 +2171,13 @@
           <a:p>
             <a:r>
               <a:rPr lang="en-US" dirty="0"/>
-              <a:t>Click once for each row. Point to the icon and do the action. Learners copy your gesture.</a:t>
+              <a:t>Click once for each row. Say each word and do the action. Learners copy your gesture.</a:t>
             </a:r>
           </a:p>
           <a:p>
             <a:r>
               <a:rPr lang="en-US" dirty="0"/>
-              <a:t>👂 Hand to your ear: "Listen."  🗣️ "Say."  ✏️ Mime writing: "Write."  👥 Point to two people: "Partner."  🚶 Walk a few steps: "Walk and talk."</a:t>
+              <a:t>Hand to your ear: "Listen."  "Say."  Mime writing: "Write."  Point to two people: "Partner."  Walk a few steps: "Walk and talk."</a:t>
             </a:r>
           </a:p>
           <a:p>
@@ -2201,13 +2201,13 @@
           <a:p>
             <a:r>
               <a:rPr lang="en-US" dirty="0"/>
-              <a:t>If you are behind: show the icons and say the 3 rules only.</a:t>
+              <a:t>If you are behind: say the 3 rules only.</a:t>
             </a:r>
           </a:p>
           <a:p>
             <a:r>
               <a:rPr lang="en-US" dirty="0"/>
-              <a:t>Source: Level1_Lesson1.md, Lesson 1 (Step 2: Orientation; Student Pages: The Icons, How Our Class Works).</a:t>
+              <a:t>Source: Level1_Lesson1.md, Lesson 1 (Step 2: Orientation; Student Pages: How Our Class Works).</a:t>
             </a:r>
           </a:p>
         </p:txBody>
@@ -2300,7 +2300,7 @@
           <a:p>
             <a:r>
               <a:rPr lang="en-US" dirty="0"/>
-              <a:t>Say: "Write one word." Point to the ✏️ icon. Do number 1 together.</a:t>
+              <a:t>Say: "Write one word." Do number 1 together.</a:t>
             </a:r>
           </a:p>
           <a:p>
@@ -3296,7 +3296,7 @@
           <a:p>
             <a:r>
               <a:rPr lang="en-US" dirty="0"/>
-              <a:t>👂 Hand to your ear: "Listen."  🗣️ Point to your mouth: "Repeat."  ✏️ Mime writing: "Write."</a:t>
+              <a:t>Hand to your ear: "Listen."  Point to your mouth: "Repeat."  Mime writing: "Write."</a:t>
             </a:r>
           </a:p>
           <a:p>
@@ -5188,7 +5188,7 @@
                 <a:ea typeface="Lexend Deca" pitchFamily="34" charset="-122"/>
                 <a:cs typeface="Lexend Deca" pitchFamily="34" charset="-120"/>
               </a:rPr>
-              <a:t>👂 ⭕  Listen. Circle the letters.</a:t>
+              <a:t>Listen. Circle the letters.</a:t>
             </a:r>
             <a:endParaRPr lang="en-US" sz="2000" dirty="0"/>
           </a:p>
@@ -5956,8 +5956,8 @@
         </p:nvSpPr>
         <p:spPr>
           <a:xfrm>
-            <a:off x="1583741" y="4550054"/>
-            <a:ext cx="5130698" cy="602590"/>
+            <a:off x="548640" y="4550054"/>
+            <a:ext cx="6163056" cy="602590"/>
           </a:xfrm>
           <a:prstGeom prst="round1Rect">
             <a:avLst>
@@ -5982,8 +5982,8 @@
         </p:nvSpPr>
         <p:spPr>
           <a:xfrm>
-            <a:off x="1583741" y="5261458"/>
-            <a:ext cx="5130698" cy="602590"/>
+            <a:off x="548640" y="5261458"/>
+            <a:ext cx="6163056" cy="602590"/>
           </a:xfrm>
           <a:prstGeom prst="round1Rect">
             <a:avLst>
@@ -6033,7 +6033,7 @@
                 <a:ea typeface="Lexend Deca" pitchFamily="34" charset="-122"/>
                 <a:cs typeface="Lexend Deca" pitchFamily="34" charset="-120"/>
               </a:rPr>
-              <a:t>👂 ✏️  Listen again.</a:t>
+              <a:t>Listen again.</a:t>
             </a:r>
             <a:endParaRPr lang="en-US" sz="2000" dirty="0"/>
           </a:p>
@@ -6164,8 +6164,8 @@
         </p:nvSpPr>
         <p:spPr>
           <a:xfrm>
-            <a:off x="1810512" y="4550054"/>
-            <a:ext cx="4754880" cy="602590"/>
+            <a:off x="777240" y="4550054"/>
+            <a:ext cx="5760720" cy="602590"/>
           </a:xfrm>
           <a:prstGeom prst="rect">
             <a:avLst/>
@@ -6214,8 +6214,8 @@
         </p:nvSpPr>
         <p:spPr>
           <a:xfrm>
-            <a:off x="1810512" y="5261458"/>
-            <a:ext cx="4754880" cy="602590"/>
+            <a:off x="777240" y="5261458"/>
+            <a:ext cx="5760720" cy="602590"/>
           </a:xfrm>
           <a:prstGeom prst="rect">
             <a:avLst/>
@@ -6440,132 +6440,6 @@
                 <a:cs typeface="Lexend Deca" pitchFamily="34" charset="-120"/>
               </a:rPr>
               <a:t>2</a:t>
-            </a:r>
-            <a:endParaRPr lang="en-US" sz="3200" dirty="0"/>
-          </a:p>
-        </p:txBody>
-      </p:sp>
-      <p:sp>
-        <p:nvSpPr>
-          <p:cNvPr id="25" name="Shape 23"/>
-          <p:cNvSpPr/>
-          <p:nvPr/>
-        </p:nvSpPr>
-        <p:spPr>
-          <a:xfrm>
-            <a:off x="544982" y="4550054"/>
-            <a:ext cx="1039673" cy="602590"/>
-          </a:xfrm>
-          <a:prstGeom prst="rect">
-            <a:avLst/>
-          </a:prstGeom>
-          <a:solidFill>
-            <a:srgbClr val="B9D2F7"/>
-          </a:solidFill>
-          <a:ln/>
-        </p:spPr>
-        <p:txBody>
-          <a:bodyPr/>
-          <a:p/>
-        </p:txBody>
-      </p:sp>
-      <p:sp>
-        <p:nvSpPr>
-          <p:cNvPr id="26" name="Text 24"/>
-          <p:cNvSpPr/>
-          <p:nvPr/>
-        </p:nvSpPr>
-        <p:spPr>
-          <a:xfrm>
-            <a:off x="686714" y="4543654"/>
-            <a:ext cx="1109167" cy="585216"/>
-          </a:xfrm>
-          <a:prstGeom prst="rect">
-            <a:avLst/>
-          </a:prstGeom>
-          <a:noFill/>
-          <a:ln/>
-        </p:spPr>
-        <p:txBody>
-          <a:bodyPr wrap="square" rtlCol="0" anchor="ctr"/>
-          <a:lstStyle/>
-          <a:p>
-            <a:pPr algn="ctr" indent="0" marL="0">
-              <a:buNone/>
-            </a:pPr>
-            <a:r>
-              <a:rPr lang="en-US" sz="3200" dirty="0" b="1">
-                <a:solidFill>
-                  <a:srgbClr val="1B2236"/>
-                </a:solidFill>
-                <a:latin typeface="Lexend Deca" pitchFamily="34" charset="0"/>
-                <a:ea typeface="Lexend Deca" pitchFamily="34" charset="-122"/>
-                <a:cs typeface="Lexend Deca" pitchFamily="34" charset="-120"/>
-              </a:rPr>
-              <a:t>🗣️</a:t>
-            </a:r>
-            <a:endParaRPr lang="en-US" sz="3200" dirty="0"/>
-          </a:p>
-        </p:txBody>
-      </p:sp>
-      <p:sp>
-        <p:nvSpPr>
-          <p:cNvPr id="27" name="Shape 25"/>
-          <p:cNvSpPr/>
-          <p:nvPr/>
-        </p:nvSpPr>
-        <p:spPr>
-          <a:xfrm>
-            <a:off x="544982" y="5279746"/>
-            <a:ext cx="1039673" cy="602590"/>
-          </a:xfrm>
-          <a:prstGeom prst="rect">
-            <a:avLst/>
-          </a:prstGeom>
-          <a:solidFill>
-            <a:srgbClr val="B9D2F7"/>
-          </a:solidFill>
-          <a:ln/>
-        </p:spPr>
-        <p:txBody>
-          <a:bodyPr/>
-          <a:p/>
-        </p:txBody>
-      </p:sp>
-      <p:sp>
-        <p:nvSpPr>
-          <p:cNvPr id="28" name="Text 26"/>
-          <p:cNvSpPr/>
-          <p:nvPr/>
-        </p:nvSpPr>
-        <p:spPr>
-          <a:xfrm>
-            <a:off x="686714" y="5269687"/>
-            <a:ext cx="1109167" cy="585216"/>
-          </a:xfrm>
-          <a:prstGeom prst="rect">
-            <a:avLst/>
-          </a:prstGeom>
-          <a:noFill/>
-          <a:ln/>
-        </p:spPr>
-        <p:txBody>
-          <a:bodyPr wrap="square" rtlCol="0" anchor="ctr"/>
-          <a:lstStyle/>
-          <a:p>
-            <a:pPr algn="ctr" indent="0" marL="0">
-              <a:buNone/>
-            </a:pPr>
-            <a:r>
-              <a:rPr lang="en-US" sz="3200" dirty="0" b="1">
-                <a:solidFill>
-                  <a:srgbClr val="1B2236"/>
-                </a:solidFill>
-                <a:latin typeface="Lexend Deca" pitchFamily="34" charset="0"/>
-                <a:ea typeface="Lexend Deca" pitchFamily="34" charset="-122"/>
-                <a:cs typeface="Lexend Deca" pitchFamily="34" charset="-120"/>
-              </a:rPr>
-              <a:t>🗣️</a:t>
             </a:r>
             <a:endParaRPr lang="en-US" sz="3200" dirty="0"/>
           </a:p>
@@ -10213,8 +10087,8 @@
         </p:nvSpPr>
         <p:spPr>
           <a:xfrm>
-            <a:off x="1583741" y="1349654"/>
-            <a:ext cx="5130698" cy="983894"/>
+            <a:off x="548640" y="1349654"/>
+            <a:ext cx="6163056" cy="983894"/>
           </a:xfrm>
           <a:prstGeom prst="round1Rect">
             <a:avLst>
@@ -10369,8 +10243,8 @@
         </p:nvSpPr>
         <p:spPr>
           <a:xfrm>
-            <a:off x="1810512" y="1417320"/>
-            <a:ext cx="4434840" cy="384048"/>
+            <a:off x="777240" y="1417320"/>
+            <a:ext cx="5440680" cy="384048"/>
           </a:xfrm>
           <a:prstGeom prst="rect">
             <a:avLst/>
@@ -10408,8 +10282,8 @@
         </p:nvSpPr>
         <p:spPr>
           <a:xfrm>
-            <a:off x="1901952" y="1819656"/>
-            <a:ext cx="4343400" cy="411480"/>
+            <a:off x="868680" y="1819656"/>
+            <a:ext cx="5349240" cy="411480"/>
           </a:xfrm>
           <a:prstGeom prst="rect">
             <a:avLst/>
@@ -10716,69 +10590,6 @@
               <a:t>Yes, I ____.</a:t>
             </a:r>
             <a:endParaRPr lang="en-US" sz="2000" dirty="0"/>
-          </a:p>
-        </p:txBody>
-      </p:sp>
-      <p:sp>
-        <p:nvSpPr>
-          <p:cNvPr id="19" name="Shape 17"/>
-          <p:cNvSpPr/>
-          <p:nvPr/>
-        </p:nvSpPr>
-        <p:spPr>
-          <a:xfrm>
-            <a:off x="544982" y="1349654"/>
-            <a:ext cx="1039673" cy="983894"/>
-          </a:xfrm>
-          <a:prstGeom prst="rect">
-            <a:avLst/>
-          </a:prstGeom>
-          <a:solidFill>
-            <a:srgbClr val="B9D2F7"/>
-          </a:solidFill>
-          <a:ln/>
-        </p:spPr>
-        <p:txBody>
-          <a:bodyPr/>
-          <a:p/>
-        </p:txBody>
-      </p:sp>
-      <p:sp>
-        <p:nvSpPr>
-          <p:cNvPr id="20" name="Text 18"/>
-          <p:cNvSpPr/>
-          <p:nvPr/>
-        </p:nvSpPr>
-        <p:spPr>
-          <a:xfrm>
-            <a:off x="686714" y="1480414"/>
-            <a:ext cx="1109167" cy="646481"/>
-          </a:xfrm>
-          <a:prstGeom prst="rect">
-            <a:avLst/>
-          </a:prstGeom>
-          <a:noFill/>
-          <a:ln/>
-        </p:spPr>
-        <p:txBody>
-          <a:bodyPr wrap="square" rtlCol="0" anchor="ctr"/>
-          <a:lstStyle/>
-          <a:p>
-            <a:pPr algn="ctr" indent="0" marL="0">
-              <a:buNone/>
-            </a:pPr>
-            <a:r>
-              <a:rPr lang="en-US" sz="3600" dirty="0" b="1">
-                <a:solidFill>
-                  <a:srgbClr val="1B2236"/>
-                </a:solidFill>
-                <a:latin typeface="Lexend Deca" pitchFamily="34" charset="0"/>
-                <a:ea typeface="Lexend Deca" pitchFamily="34" charset="-122"/>
-                <a:cs typeface="Lexend Deca" pitchFamily="34" charset="-120"/>
-              </a:rPr>
-              <a:t>✏️</a:t>
-            </a:r>
-            <a:endParaRPr lang="en-US" sz="3600" dirty="0"/>
           </a:p>
         </p:txBody>
       </p:sp>
@@ -13195,7 +13006,7 @@
                 <a:ea typeface="Lexend Deca" pitchFamily="34" charset="-122"/>
                 <a:cs typeface="Lexend Deca" pitchFamily="34" charset="-120"/>
               </a:rPr>
-              <a:t>🚶 🗣️ ✏️</a:t>
+              <a:t>Walk and talk.</a:t>
             </a:r>
             <a:endParaRPr lang="en-US" sz="2000" dirty="0"/>
           </a:p>
@@ -13622,7 +13433,7 @@
                 <a:ea typeface="Lexend Deca" pitchFamily="34" charset="-122"/>
                 <a:cs typeface="Lexend Deca" pitchFamily="34" charset="-120"/>
               </a:rPr>
-              <a:t>✏️ Write the name.</a:t>
+              <a:t>Write the name.</a:t>
             </a:r>
             <a:endParaRPr lang="en-US" sz="2200" dirty="0"/>
           </a:p>
@@ -13727,7 +13538,7 @@
                 <a:ea typeface="Lexend Deca" pitchFamily="34" charset="-122"/>
                 <a:cs typeface="Lexend Deca" pitchFamily="34" charset="-120"/>
               </a:rPr>
-              <a:t>✅ Your partner checks.</a:t>
+              <a:t>Your partner checks.</a:t>
             </a:r>
             <a:endParaRPr lang="en-US" sz="2200" dirty="0"/>
           </a:p>
@@ -14550,7 +14361,7 @@
                 <a:ea typeface="Lexend Deca" pitchFamily="34" charset="-122"/>
                 <a:cs typeface="Lexend Deca" pitchFamily="34" charset="-120"/>
               </a:rPr>
-              <a:t>🏠 Homework</a:t>
+              <a:t>Homework</a:t>
             </a:r>
             <a:endParaRPr lang="en-US" sz="2200" dirty="0"/>
           </a:p>
@@ -14596,7 +14407,7 @@
                 <a:ea typeface="Lexend Deca" pitchFamily="34" charset="-122"/>
                 <a:cs typeface="Lexend Deca" pitchFamily="34" charset="-120"/>
               </a:rPr>
-              <a:t>1. ✏️ Write your name.</a:t>
+              <a:t>1. Write your name.</a:t>
             </a:r>
             <a:endParaRPr lang="en-US" sz="2000" dirty="0"/>
           </a:p>
@@ -14616,7 +14427,7 @@
                 <a:ea typeface="Lexend Deca" pitchFamily="34" charset="-122"/>
                 <a:cs typeface="Lexend Deca" pitchFamily="34" charset="-120"/>
               </a:rPr>
-              <a:t>2. 🗣️ Ask a friend's name.</a:t>
+              <a:t>2. Ask a friend's name.</a:t>
             </a:r>
             <a:endParaRPr lang="en-US" sz="2000" dirty="0"/>
           </a:p>
@@ -14636,7 +14447,7 @@
                 <a:ea typeface="Lexend Deca" pitchFamily="34" charset="-122"/>
                 <a:cs typeface="Lexend Deca" pitchFamily="34" charset="-120"/>
               </a:rPr>
-              <a:t>3. 📖 Write the words.</a:t>
+              <a:t>3. Write the words.</a:t>
             </a:r>
             <a:endParaRPr lang="en-US" sz="2000" dirty="0"/>
           </a:p>
@@ -14656,7 +14467,7 @@
                 <a:ea typeface="Lexend Deca" pitchFamily="34" charset="-122"/>
                 <a:cs typeface="Lexend Deca" pitchFamily="34" charset="-120"/>
               </a:rPr>
-              <a:t>4. 🗣️ Say A to Z, 2 times.</a:t>
+              <a:t>4. Say A to Z, 2 times.</a:t>
             </a:r>
             <a:endParaRPr lang="en-US" sz="2000" dirty="0"/>
           </a:p>
@@ -19156,7 +18967,7 @@
                 <a:ea typeface="Lexend Deca" pitchFamily="34" charset="-122"/>
                 <a:cs typeface="Lexend Deca" pitchFamily="34" charset="-120"/>
               </a:rPr>
-              <a:t>👂 ⭕  Listen to the teacher.</a:t>
+              <a:t>Listen to the teacher.</a:t>
             </a:r>
             <a:endParaRPr lang="en-US" sz="2200" dirty="0"/>
           </a:p>
@@ -20818,7 +20629,7 @@
                 <a:ea typeface="Lexend Deca" pitchFamily="34" charset="-122"/>
                 <a:cs typeface="Lexend Deca" pitchFamily="34" charset="-120"/>
               </a:rPr>
-              <a:t>D. ✅ I can…</a:t>
+              <a:t>D. I can…</a:t>
             </a:r>
             <a:endParaRPr lang="en-US" sz="2200" dirty="0"/>
           </a:p>
@@ -21173,7 +20984,7 @@
                 <a:ea typeface="Lexend Deca" pitchFamily="34" charset="-122"/>
                 <a:cs typeface="Lexend Deca" pitchFamily="34" charset="-120"/>
               </a:rPr>
-              <a:t>📖 🔗 Question</a:t>
+              <a:t>Match the question</a:t>
             </a:r>
             <a:endParaRPr lang="en-US" sz="2200" dirty="0"/>
           </a:p>
@@ -22589,7 +22400,7 @@
                 <a:ea typeface="Lexend Deca" pitchFamily="34" charset="-122"/>
                 <a:cs typeface="Lexend Deca" pitchFamily="34" charset="-120"/>
               </a:rPr>
-              <a:t>Task icons are standard emoji characters shown with the computer's emoji font.</a:t>
+              <a:t>Other small pictures (for example, the faces on the Progress Check) are standard emoji characters shown with the computer's emoji font.</a:t>
             </a:r>
             <a:endParaRPr lang="en-US" sz="2200" dirty="0"/>
           </a:p>
@@ -23414,8 +23225,8 @@
         </p:nvSpPr>
         <p:spPr>
           <a:xfrm>
-            <a:off x="544982" y="2093062"/>
-            <a:ext cx="6227064" cy="983894"/>
+            <a:off x="548640" y="2414015"/>
+            <a:ext cx="6163056" cy="603504"/>
           </a:xfrm>
           <a:prstGeom prst="round1Rect">
             <a:avLst>
@@ -23440,8 +23251,8 @@
         </p:nvSpPr>
         <p:spPr>
           <a:xfrm>
-            <a:off x="1583741" y="2035454"/>
-            <a:ext cx="5130698" cy="983894"/>
+            <a:off x="1583741" y="2414015"/>
+            <a:ext cx="5130698" cy="603504"/>
           </a:xfrm>
           <a:prstGeom prst="round1Rect">
             <a:avLst>
@@ -23570,8 +23381,8 @@
         </p:nvSpPr>
         <p:spPr>
           <a:xfrm>
-            <a:off x="1810512" y="2103120"/>
-            <a:ext cx="4434840" cy="384048"/>
+            <a:off x="1810512" y="2414015"/>
+            <a:ext cx="4434840" cy="603504"/>
           </a:xfrm>
           <a:prstGeom prst="rect">
             <a:avLst/>
@@ -23580,22 +23391,22 @@
           <a:ln/>
         </p:spPr>
         <p:txBody>
-          <a:bodyPr wrap="square" rtlCol="0" anchor="t"/>
+          <a:bodyPr wrap="square" rtlCol="0" anchor="ctr"/>
           <a:lstStyle/>
           <a:p>
             <a:pPr algn="l" indent="0" marL="0">
               <a:buNone/>
             </a:pPr>
             <a:r>
-              <a:rPr lang="en-US" sz="2000" dirty="0" b="1">
-                <a:solidFill>
-                  <a:srgbClr val="1B2236"/>
-                </a:solidFill>
-                <a:latin typeface="Lexend Deca" pitchFamily="34" charset="0"/>
-                <a:ea typeface="Lexend Deca" pitchFamily="34" charset="-122"/>
-                <a:cs typeface="Lexend Deca" pitchFamily="34" charset="-120"/>
-              </a:rPr>
-              <a:t>👂  Listen.</a:t>
+              <a:rPr lang="en-US" sz="2000" dirty="0" b="0">
+                <a:solidFill>
+                  <a:srgbClr val="1B2236"/>
+                </a:solidFill>
+                <a:latin typeface="Lexend Deca" pitchFamily="34" charset="0"/>
+                <a:ea typeface="Lexend Deca" pitchFamily="34" charset="-122"/>
+                <a:cs typeface="Lexend Deca" pitchFamily="34" charset="-120"/>
+              </a:rPr>
+              <a:t>Listen.</a:t>
             </a:r>
             <a:endParaRPr lang="en-US" sz="2000" dirty="0"/>
           </a:p>
@@ -23603,52 +23414,13 @@
       </p:sp>
       <p:sp>
         <p:nvSpPr>
-          <p:cNvPr id="9" name="Text 7"/>
-          <p:cNvSpPr/>
-          <p:nvPr/>
-        </p:nvSpPr>
-        <p:spPr>
-          <a:xfrm>
-            <a:off x="1901952" y="2505456"/>
-            <a:ext cx="4343400" cy="411480"/>
-          </a:xfrm>
-          <a:prstGeom prst="rect">
-            <a:avLst/>
-          </a:prstGeom>
-          <a:noFill/>
-          <a:ln/>
-        </p:spPr>
-        <p:txBody>
-          <a:bodyPr wrap="square" lIns="0" tIns="0" rIns="0" bIns="0" rtlCol="0" anchor="t"/>
-          <a:lstStyle/>
-          <a:p>
-            <a:pPr algn="l" indent="0" marL="0">
-              <a:buNone/>
-            </a:pPr>
-            <a:r>
-              <a:rPr lang="en-US" sz="2000" dirty="0">
-                <a:solidFill>
-                  <a:srgbClr val="1B2236"/>
-                </a:solidFill>
-                <a:latin typeface="Lexend Deca" pitchFamily="34" charset="0"/>
-                <a:ea typeface="Lexend Deca" pitchFamily="34" charset="-122"/>
-                <a:cs typeface="Lexend Deca" pitchFamily="34" charset="-120"/>
-              </a:rPr>
-              <a:t>Every task has an icon.</a:t>
-            </a:r>
-            <a:endParaRPr lang="en-US" sz="2000" dirty="0"/>
-          </a:p>
-        </p:txBody>
-      </p:sp>
-      <p:sp>
-        <p:nvSpPr>
           <p:cNvPr id="10" name="Shape 8"/>
           <p:cNvSpPr/>
           <p:nvPr/>
         </p:nvSpPr>
         <p:spPr>
           <a:xfrm rot="10800000">
-            <a:off x="6361481" y="2230222"/>
+            <a:off x="6361481" y="2551175"/>
             <a:ext cx="88697" cy="76810"/>
           </a:xfrm>
           <a:prstGeom prst="triangle">
@@ -23697,7 +23469,7 @@
                 <a:ea typeface="Lexend Deca" pitchFamily="34" charset="-122"/>
                 <a:cs typeface="Lexend Deca" pitchFamily="34" charset="-120"/>
               </a:rPr>
-              <a:t>🗣️  Say. Repeat.</a:t>
+              <a:t>Say. Repeat.</a:t>
             </a:r>
             <a:endParaRPr lang="en-US" sz="2000" dirty="0"/>
           </a:p>
@@ -23760,7 +23532,7 @@
                 <a:ea typeface="Lexend Deca" pitchFamily="34" charset="-122"/>
                 <a:cs typeface="Lexend Deca" pitchFamily="34" charset="-120"/>
               </a:rPr>
-              <a:t>✏️  Write.</a:t>
+              <a:t>Write.</a:t>
             </a:r>
             <a:endParaRPr lang="en-US" sz="2000" dirty="0"/>
           </a:p>
@@ -23823,7 +23595,7 @@
                 <a:ea typeface="Lexend Deca" pitchFamily="34" charset="-122"/>
                 <a:cs typeface="Lexend Deca" pitchFamily="34" charset="-120"/>
               </a:rPr>
-              <a:t>👥  Work with a partner.</a:t>
+              <a:t>Work with a partner.</a:t>
             </a:r>
             <a:endParaRPr lang="en-US" sz="2000" dirty="0"/>
           </a:p>
@@ -23886,7 +23658,7 @@
                 <a:ea typeface="Lexend Deca" pitchFamily="34" charset="-122"/>
                 <a:cs typeface="Lexend Deca" pitchFamily="34" charset="-120"/>
               </a:rPr>
-              <a:t>🚶  Walk and talk.</a:t>
+              <a:t>Walk and talk.</a:t>
             </a:r>
             <a:endParaRPr lang="en-US" sz="2000" dirty="0"/>
           </a:p>
@@ -23924,8 +23696,8 @@
         </p:nvSpPr>
         <p:spPr>
           <a:xfrm>
-            <a:off x="544982" y="2035454"/>
-            <a:ext cx="1039673" cy="983894"/>
+            <a:off x="544982" y="2414015"/>
+            <a:ext cx="1039673" cy="603504"/>
           </a:xfrm>
           <a:prstGeom prst="rect">
             <a:avLst/>
@@ -23948,8 +23720,8 @@
         </p:nvSpPr>
         <p:spPr>
           <a:xfrm>
-            <a:off x="686714" y="2166214"/>
-            <a:ext cx="1109167" cy="646481"/>
+            <a:off x="686714" y="2395727"/>
+            <a:ext cx="1109167" cy="585216"/>
           </a:xfrm>
           <a:prstGeom prst="rect">
             <a:avLst/>
@@ -24430,7 +24202,7 @@
         </p:nvSpPr>
         <p:spPr>
           <a:xfrm>
-            <a:off x="6184087" y="1804111"/>
+            <a:off x="6184087" y="2176272"/>
             <a:ext cx="727862" cy="687570"/>
           </a:xfrm>
           <a:prstGeom prst="star10">
@@ -24454,7 +24226,7 @@
         </p:nvSpPr>
         <p:spPr>
           <a:xfrm>
-            <a:off x="6242576" y="1795013"/>
+            <a:off x="6242576" y="2167127"/>
             <a:ext cx="740860" cy="740860"/>
           </a:xfrm>
           <a:prstGeom prst="star10">
@@ -24478,7 +24250,7 @@
         </p:nvSpPr>
         <p:spPr>
           <a:xfrm rot="900000">
-            <a:off x="6444038" y="2007523"/>
+            <a:off x="6444038" y="2386584"/>
             <a:ext cx="316490" cy="316490"/>
           </a:xfrm>
           <a:prstGeom prst="mathPlus">
@@ -24688,41 +24460,6 @@
                                         <p:cTn id="19" dur="400"/>
                                         <p:tgtEl>
                                           <p:spTgt spid="8"/>
-                                        </p:tgtEl>
-                                      </p:cBhvr>
-                                    </p:animEffect>
-                                  </p:childTnLst>
-                                </p:cTn>
-                              </p:par>
-                              <p:par>
-                                <p:cTn id="20" presetID="10" presetClass="entr" presetSubtype="0" fill="hold" nodeType="withEffect">
-                                  <p:stCondLst>
-                                    <p:cond delay="0"/>
-                                  </p:stCondLst>
-                                  <p:childTnLst>
-                                    <p:set>
-                                      <p:cBhvr>
-                                        <p:cTn id="21" dur="1" fill="hold">
-                                          <p:stCondLst>
-                                            <p:cond delay="0"/>
-                                          </p:stCondLst>
-                                        </p:cTn>
-                                        <p:tgtEl>
-                                          <p:spTgt spid="9"/>
-                                        </p:tgtEl>
-                                        <p:attrNameLst>
-                                          <p:attrName>style.visibility</p:attrName>
-                                        </p:attrNameLst>
-                                      </p:cBhvr>
-                                      <p:to>
-                                        <p:strVal val="visible"/>
-                                      </p:to>
-                                    </p:set>
-                                    <p:animEffect transition="in" filter="fade">
-                                      <p:cBhvr>
-                                        <p:cTn id="22" dur="400"/>
-                                        <p:tgtEl>
-                                          <p:spTgt spid="9"/>
                                         </p:tgtEl>
                                       </p:cBhvr>
                                     </p:animEffect>
@@ -27034,7 +26771,7 @@
                 <a:ea typeface="Lexend Deca" pitchFamily="34" charset="-122"/>
                 <a:cs typeface="Lexend Deca" pitchFamily="34" charset="-120"/>
               </a:rPr>
-              <a:t>👥 ☝️ 🗣️</a:t>
+              <a:t>Partner game:</a:t>
             </a:r>
             <a:endParaRPr lang="en-US" sz="2200" dirty="0"/>
           </a:p>
@@ -27957,7 +27694,7 @@
                 <a:ea typeface="Lexend Deca" pitchFamily="34" charset="-122"/>
                 <a:cs typeface="Lexend Deca" pitchFamily="34" charset="-120"/>
               </a:rPr>
-              <a:t>☝️ 🗣️  Look at the picture. Say the word.</a:t>
+              <a:t>Look at the picture. Say the word.</a:t>
             </a:r>
             <a:endParaRPr lang="en-US" sz="2400" dirty="0"/>
           </a:p>
@@ -29394,8 +29131,8 @@
         </p:nvSpPr>
         <p:spPr>
           <a:xfrm>
-            <a:off x="5349240" y="4251960"/>
-            <a:ext cx="2606040" cy="548640"/>
+            <a:off x="4389120" y="4251960"/>
+            <a:ext cx="3566160" cy="548640"/>
           </a:xfrm>
           <a:prstGeom prst="roundRect">
             <a:avLst>
@@ -29435,14 +29172,14 @@
       </p:sp>
       <p:sp>
         <p:nvSpPr>
-          <p:cNvPr id="26" name="Wh 1"/>
+          <p:cNvPr id="27" name="Helper 1"/>
           <p:cNvSpPr/>
           <p:nvPr/>
         </p:nvSpPr>
         <p:spPr>
           <a:xfrm>
             <a:off x="4389120" y="4251960"/>
-            <a:ext cx="960120" cy="548640"/>
+            <a:ext cx="3566160" cy="548640"/>
           </a:xfrm>
           <a:prstGeom prst="rect">
             <a:avLst/>
@@ -29458,19 +29195,19 @@
           </a:bodyPr>
           <a:lstStyle/>
           <a:p>
-            <a:pPr algn="l" indent="0" marL="0">
-              <a:buNone/>
-            </a:pPr>
-            <a:r>
-              <a:rPr lang="en-US" sz="2200" dirty="0">
-                <a:solidFill>
-                  <a:srgbClr val="1B2236"/>
-                </a:solidFill>
-                <a:latin typeface="Lexend Deca" pitchFamily="34" charset="0"/>
-                <a:ea typeface="Lexend Deca" pitchFamily="34" charset="-122"/>
-                <a:cs typeface="Lexend Deca" pitchFamily="34" charset="-120"/>
-              </a:rPr>
-              <a:t>👂</a:t>
+            <a:pPr algn="ctr" indent="0" marL="0">
+              <a:buNone/>
+            </a:pPr>
+            <a:r>
+              <a:rPr lang="en-US" sz="2200" dirty="0" b="1">
+                <a:solidFill>
+                  <a:srgbClr val="1B2236"/>
+                </a:solidFill>
+                <a:latin typeface="Lexend Deca" pitchFamily="34" charset="0"/>
+                <a:ea typeface="Lexend Deca" pitchFamily="34" charset="-122"/>
+                <a:cs typeface="Lexend Deca" pitchFamily="34" charset="-120"/>
+              </a:rPr>
+              <a:t>Listen.</a:t>
             </a:r>
             <a:endParaRPr lang="en-US" sz="2200" dirty="0"/>
           </a:p>
@@ -29478,57 +29215,14 @@
       </p:sp>
       <p:sp>
         <p:nvSpPr>
-          <p:cNvPr id="27" name="Helper 1"/>
-          <p:cNvSpPr/>
-          <p:nvPr/>
-        </p:nvSpPr>
-        <p:spPr>
-          <a:xfrm>
-            <a:off x="5349240" y="4251960"/>
-            <a:ext cx="2606040" cy="548640"/>
-          </a:xfrm>
-          <a:prstGeom prst="rect">
-            <a:avLst/>
-          </a:prstGeom>
-          <a:noFill/>
-          <a:ln w="38100">
-            <a:noFill/>
-          </a:ln>
-        </p:spPr>
-        <p:txBody>
-          <a:bodyPr wrap="square" lIns="0" tIns="36576" rIns="0" bIns="36576" rtlCol="0" anchor="ctr">
-            <a:noAutofit/>
-          </a:bodyPr>
-          <a:lstStyle/>
-          <a:p>
-            <a:pPr algn="ctr" indent="0" marL="0">
-              <a:buNone/>
-            </a:pPr>
-            <a:r>
-              <a:rPr lang="en-US" sz="2200" dirty="0" b="1">
-                <a:solidFill>
-                  <a:srgbClr val="1B2236"/>
-                </a:solidFill>
-                <a:latin typeface="Lexend Deca" pitchFamily="34" charset="0"/>
-                <a:ea typeface="Lexend Deca" pitchFamily="34" charset="-122"/>
-                <a:cs typeface="Lexend Deca" pitchFamily="34" charset="-120"/>
-              </a:rPr>
-              <a:t>Listen.</a:t>
-            </a:r>
-            <a:endParaRPr lang="en-US" sz="2200" dirty="0"/>
-          </a:p>
-        </p:txBody>
-      </p:sp>
-      <p:sp>
-        <p:nvSpPr>
           <p:cNvPr id="29" name="Highlight 2"/>
           <p:cNvSpPr/>
           <p:nvPr/>
         </p:nvSpPr>
         <p:spPr>
           <a:xfrm>
-            <a:off x="5349240" y="5056632"/>
-            <a:ext cx="2606040" cy="548640"/>
+            <a:off x="4389120" y="5056632"/>
+            <a:ext cx="3566160" cy="548640"/>
           </a:xfrm>
           <a:prstGeom prst="roundRect">
             <a:avLst>
@@ -29568,14 +29262,14 @@
       </p:sp>
       <p:sp>
         <p:nvSpPr>
-          <p:cNvPr id="30" name="Wh 2"/>
+          <p:cNvPr id="31" name="Helper 2"/>
           <p:cNvSpPr/>
           <p:nvPr/>
         </p:nvSpPr>
         <p:spPr>
           <a:xfrm>
             <a:off x="4389120" y="5056632"/>
-            <a:ext cx="960120" cy="548640"/>
+            <a:ext cx="3566160" cy="548640"/>
           </a:xfrm>
           <a:prstGeom prst="rect">
             <a:avLst/>
@@ -29591,19 +29285,19 @@
           </a:bodyPr>
           <a:lstStyle/>
           <a:p>
-            <a:pPr algn="l" indent="0" marL="0">
-              <a:buNone/>
-            </a:pPr>
-            <a:r>
-              <a:rPr lang="en-US" sz="2200" dirty="0">
-                <a:solidFill>
-                  <a:srgbClr val="1B2236"/>
-                </a:solidFill>
-                <a:latin typeface="Lexend Deca" pitchFamily="34" charset="0"/>
-                <a:ea typeface="Lexend Deca" pitchFamily="34" charset="-122"/>
-                <a:cs typeface="Lexend Deca" pitchFamily="34" charset="-120"/>
-              </a:rPr>
-              <a:t>🗣️</a:t>
+            <a:pPr algn="ctr" indent="0" marL="0">
+              <a:buNone/>
+            </a:pPr>
+            <a:r>
+              <a:rPr lang="en-US" sz="2200" dirty="0" b="1">
+                <a:solidFill>
+                  <a:srgbClr val="1B2236"/>
+                </a:solidFill>
+                <a:latin typeface="Lexend Deca" pitchFamily="34" charset="0"/>
+                <a:ea typeface="Lexend Deca" pitchFamily="34" charset="-122"/>
+                <a:cs typeface="Lexend Deca" pitchFamily="34" charset="-120"/>
+              </a:rPr>
+              <a:t>Repeat.</a:t>
             </a:r>
             <a:endParaRPr lang="en-US" sz="2200" dirty="0"/>
           </a:p>
@@ -29611,57 +29305,14 @@
       </p:sp>
       <p:sp>
         <p:nvSpPr>
-          <p:cNvPr id="31" name="Helper 2"/>
-          <p:cNvSpPr/>
-          <p:nvPr/>
-        </p:nvSpPr>
-        <p:spPr>
-          <a:xfrm>
-            <a:off x="5349240" y="5056632"/>
-            <a:ext cx="2606040" cy="548640"/>
-          </a:xfrm>
-          <a:prstGeom prst="rect">
-            <a:avLst/>
-          </a:prstGeom>
-          <a:noFill/>
-          <a:ln w="38100">
-            <a:noFill/>
-          </a:ln>
-        </p:spPr>
-        <p:txBody>
-          <a:bodyPr wrap="square" lIns="0" tIns="36576" rIns="0" bIns="36576" rtlCol="0" anchor="ctr">
-            <a:noAutofit/>
-          </a:bodyPr>
-          <a:lstStyle/>
-          <a:p>
-            <a:pPr algn="ctr" indent="0" marL="0">
-              <a:buNone/>
-            </a:pPr>
-            <a:r>
-              <a:rPr lang="en-US" sz="2200" dirty="0" b="1">
-                <a:solidFill>
-                  <a:srgbClr val="1B2236"/>
-                </a:solidFill>
-                <a:latin typeface="Lexend Deca" pitchFamily="34" charset="0"/>
-                <a:ea typeface="Lexend Deca" pitchFamily="34" charset="-122"/>
-                <a:cs typeface="Lexend Deca" pitchFamily="34" charset="-120"/>
-              </a:rPr>
-              <a:t>Repeat.</a:t>
-            </a:r>
-            <a:endParaRPr lang="en-US" sz="2200" dirty="0"/>
-          </a:p>
-        </p:txBody>
-      </p:sp>
-      <p:sp>
-        <p:nvSpPr>
           <p:cNvPr id="33" name="Highlight 3"/>
           <p:cNvSpPr/>
           <p:nvPr/>
         </p:nvSpPr>
         <p:spPr>
           <a:xfrm>
-            <a:off x="5349240" y="5861304"/>
-            <a:ext cx="2606040" cy="548640"/>
+            <a:off x="4389120" y="5861304"/>
+            <a:ext cx="3566160" cy="548640"/>
           </a:xfrm>
           <a:prstGeom prst="roundRect">
             <a:avLst>
@@ -29701,14 +29352,14 @@
       </p:sp>
       <p:sp>
         <p:nvSpPr>
-          <p:cNvPr id="34" name="Wh 3"/>
+          <p:cNvPr id="35" name="Helper 3"/>
           <p:cNvSpPr/>
           <p:nvPr/>
         </p:nvSpPr>
         <p:spPr>
           <a:xfrm>
             <a:off x="4389120" y="5861304"/>
-            <a:ext cx="960120" cy="548640"/>
+            <a:ext cx="3566160" cy="548640"/>
           </a:xfrm>
           <a:prstGeom prst="rect">
             <a:avLst/>
@@ -29724,19 +29375,19 @@
           </a:bodyPr>
           <a:lstStyle/>
           <a:p>
-            <a:pPr algn="l" indent="0" marL="0">
-              <a:buNone/>
-            </a:pPr>
-            <a:r>
-              <a:rPr lang="en-US" sz="2200" dirty="0">
-                <a:solidFill>
-                  <a:srgbClr val="1B2236"/>
-                </a:solidFill>
-                <a:latin typeface="Lexend Deca" pitchFamily="34" charset="0"/>
-                <a:ea typeface="Lexend Deca" pitchFamily="34" charset="-122"/>
-                <a:cs typeface="Lexend Deca" pitchFamily="34" charset="-120"/>
-              </a:rPr>
-              <a:t>✏️</a:t>
+            <a:pPr algn="ctr" indent="0" marL="0">
+              <a:buNone/>
+            </a:pPr>
+            <a:r>
+              <a:rPr lang="en-US" sz="2200" dirty="0" b="1">
+                <a:solidFill>
+                  <a:srgbClr val="1B2236"/>
+                </a:solidFill>
+                <a:latin typeface="Lexend Deca" pitchFamily="34" charset="0"/>
+                <a:ea typeface="Lexend Deca" pitchFamily="34" charset="-122"/>
+                <a:cs typeface="Lexend Deca" pitchFamily="34" charset="-120"/>
+              </a:rPr>
+              <a:t>Write.</a:t>
             </a:r>
             <a:endParaRPr lang="en-US" sz="2200" dirty="0"/>
           </a:p>
@@ -29744,14 +29395,14 @@
       </p:sp>
       <p:sp>
         <p:nvSpPr>
-          <p:cNvPr id="35" name="Helper 3"/>
-          <p:cNvSpPr/>
-          <p:nvPr/>
-        </p:nvSpPr>
-        <p:spPr>
-          <a:xfrm>
-            <a:off x="5349240" y="5861304"/>
-            <a:ext cx="2606040" cy="548640"/>
+          <p:cNvPr id="37" name="Order head"/>
+          <p:cNvSpPr/>
+          <p:nvPr/>
+        </p:nvSpPr>
+        <p:spPr>
+          <a:xfrm>
+            <a:off x="8549640" y="1280160"/>
+            <a:ext cx="3017520" cy="548640"/>
           </a:xfrm>
           <a:prstGeom prst="rect">
             <a:avLst/>
@@ -29762,39 +29413,39 @@
           </a:ln>
         </p:spPr>
         <p:txBody>
-          <a:bodyPr wrap="square" lIns="0" tIns="36576" rIns="0" bIns="36576" rtlCol="0" anchor="ctr">
+          <a:bodyPr wrap="square" lIns="73152" tIns="36576" rIns="73152" bIns="36576" rtlCol="0" anchor="ctr">
             <a:noAutofit/>
           </a:bodyPr>
           <a:lstStyle/>
           <a:p>
-            <a:pPr algn="ctr" indent="0" marL="0">
-              <a:buNone/>
-            </a:pPr>
-            <a:r>
-              <a:rPr lang="en-US" sz="2200" dirty="0" b="1">
-                <a:solidFill>
-                  <a:srgbClr val="1B2236"/>
-                </a:solidFill>
-                <a:latin typeface="Lexend Deca" pitchFamily="34" charset="0"/>
-                <a:ea typeface="Lexend Deca" pitchFamily="34" charset="-122"/>
-                <a:cs typeface="Lexend Deca" pitchFamily="34" charset="-120"/>
-              </a:rPr>
-              <a:t>Write.</a:t>
-            </a:r>
-            <a:endParaRPr lang="en-US" sz="2200" dirty="0"/>
-          </a:p>
-        </p:txBody>
-      </p:sp>
-      <p:sp>
-        <p:nvSpPr>
-          <p:cNvPr id="37" name="Order head"/>
-          <p:cNvSpPr/>
-          <p:nvPr/>
-        </p:nvSpPr>
-        <p:spPr>
-          <a:xfrm>
-            <a:off x="8549640" y="1280160"/>
-            <a:ext cx="3017520" cy="548640"/>
+            <a:pPr algn="l" indent="0" marL="0">
+              <a:buNone/>
+            </a:pPr>
+            <a:r>
+              <a:rPr lang="en-US" sz="2400" dirty="0" b="1">
+                <a:solidFill>
+                  <a:srgbClr val="1B2236"/>
+                </a:solidFill>
+                <a:latin typeface="Lexend Deca" pitchFamily="34" charset="0"/>
+                <a:ea typeface="Lexend Deca" pitchFamily="34" charset="-122"/>
+                <a:cs typeface="Lexend Deca" pitchFamily="34" charset="-120"/>
+              </a:rPr>
+              <a:t>Help!</a:t>
+            </a:r>
+            <a:endParaRPr lang="en-US" sz="2400" dirty="0"/>
+          </a:p>
+        </p:txBody>
+      </p:sp>
+      <p:sp>
+        <p:nvSpPr>
+          <p:cNvPr id="39" name="Step 1"/>
+          <p:cNvSpPr/>
+          <p:nvPr/>
+        </p:nvSpPr>
+        <p:spPr>
+          <a:xfrm>
+            <a:off x="8549640" y="1965960"/>
+            <a:ext cx="3063240" cy="914400"/>
           </a:xfrm>
           <a:prstGeom prst="rect">
             <a:avLst/>
@@ -29814,60 +29465,15 @@
               <a:buNone/>
             </a:pPr>
             <a:r>
-              <a:rPr lang="en-US" sz="2400" dirty="0" b="1">
-                <a:solidFill>
-                  <a:srgbClr val="1B2236"/>
-                </a:solidFill>
-                <a:latin typeface="Lexend Deca" pitchFamily="34" charset="0"/>
-                <a:ea typeface="Lexend Deca" pitchFamily="34" charset="-122"/>
-                <a:cs typeface="Lexend Deca" pitchFamily="34" charset="-120"/>
-              </a:rPr>
-              <a:t>Help!</a:t>
-            </a:r>
-            <a:endParaRPr lang="en-US" sz="2400" dirty="0"/>
-          </a:p>
-        </p:txBody>
-      </p:sp>
-      <p:sp>
-        <p:nvSpPr>
-          <p:cNvPr id="38" name="Step num 1"/>
-          <p:cNvSpPr/>
-          <p:nvPr/>
-        </p:nvSpPr>
-        <p:spPr>
-          <a:xfrm>
-            <a:off x="8549640" y="1965960"/>
-            <a:ext cx="548640" cy="548640"/>
-          </a:xfrm>
-          <a:prstGeom prst="ellipse">
-            <a:avLst/>
-          </a:prstGeom>
-          <a:solidFill>
-            <a:srgbClr val="FFFFFF"/>
-          </a:solidFill>
-          <a:ln w="38100">
-            <a:noFill/>
-          </a:ln>
-        </p:spPr>
-        <p:txBody>
-          <a:bodyPr wrap="square" lIns="0" tIns="36576" rIns="0" bIns="36576" rtlCol="0" anchor="ctr">
-            <a:noAutofit/>
-          </a:bodyPr>
-          <a:lstStyle/>
-          <a:p>
-            <a:pPr algn="ctr" indent="0" marL="0">
-              <a:buNone/>
-            </a:pPr>
-            <a:r>
-              <a:rPr lang="en-US" sz="2200" dirty="0" b="1">
-                <a:solidFill>
-                  <a:srgbClr val="1B2236"/>
-                </a:solidFill>
-                <a:latin typeface="Lexend Deca" pitchFamily="34" charset="0"/>
-                <a:ea typeface="Lexend Deca" pitchFamily="34" charset="-122"/>
-                <a:cs typeface="Lexend Deca" pitchFamily="34" charset="-120"/>
-              </a:rPr>
-              <a:t>🔁</a:t>
+              <a:rPr lang="en-US" sz="2200" dirty="0">
+                <a:solidFill>
+                  <a:srgbClr val="1B2236"/>
+                </a:solidFill>
+                <a:latin typeface="Lexend Deca" pitchFamily="34" charset="0"/>
+                <a:ea typeface="Lexend Deca" pitchFamily="34" charset="-122"/>
+                <a:cs typeface="Lexend Deca" pitchFamily="34" charset="-120"/>
+              </a:rPr>
+              <a:t>Can you repeat, please?</a:t>
             </a:r>
             <a:endParaRPr lang="en-US" sz="2200" dirty="0"/>
           </a:p>
@@ -29875,14 +29481,14 @@
       </p:sp>
       <p:sp>
         <p:nvSpPr>
-          <p:cNvPr id="39" name="Step 1"/>
-          <p:cNvSpPr/>
-          <p:nvPr/>
-        </p:nvSpPr>
-        <p:spPr>
-          <a:xfrm>
-            <a:off x="9235440" y="1965960"/>
-            <a:ext cx="2377440" cy="914400"/>
+          <p:cNvPr id="41" name="Step 2"/>
+          <p:cNvSpPr/>
+          <p:nvPr/>
+        </p:nvSpPr>
+        <p:spPr>
+          <a:xfrm>
+            <a:off x="8549640" y="3017520"/>
+            <a:ext cx="3063240" cy="914400"/>
           </a:xfrm>
           <a:prstGeom prst="rect">
             <a:avLst/>
@@ -29910,7 +29516,7 @@
                 <a:ea typeface="Lexend Deca" pitchFamily="34" charset="-122"/>
                 <a:cs typeface="Lexend Deca" pitchFamily="34" charset="-120"/>
               </a:rPr>
-              <a:t>Can you repeat, please?</a:t>
+              <a:t>I don't understand.</a:t>
             </a:r>
             <a:endParaRPr lang="en-US" sz="2200" dirty="0"/>
           </a:p>
@@ -29918,147 +29524,14 @@
       </p:sp>
       <p:sp>
         <p:nvSpPr>
-          <p:cNvPr id="40" name="Step num 2"/>
-          <p:cNvSpPr/>
-          <p:nvPr/>
-        </p:nvSpPr>
-        <p:spPr>
-          <a:xfrm>
-            <a:off x="8549640" y="3017520"/>
-            <a:ext cx="548640" cy="548640"/>
-          </a:xfrm>
-          <a:prstGeom prst="ellipse">
-            <a:avLst/>
-          </a:prstGeom>
-          <a:solidFill>
-            <a:srgbClr val="FFFFFF"/>
-          </a:solidFill>
-          <a:ln w="38100">
-            <a:noFill/>
-          </a:ln>
-        </p:spPr>
-        <p:txBody>
-          <a:bodyPr wrap="square" lIns="0" tIns="36576" rIns="0" bIns="36576" rtlCol="0" anchor="ctr">
-            <a:noAutofit/>
-          </a:bodyPr>
-          <a:lstStyle/>
-          <a:p>
-            <a:pPr algn="ctr" indent="0" marL="0">
-              <a:buNone/>
-            </a:pPr>
-            <a:r>
-              <a:rPr lang="en-US" sz="2200" dirty="0" b="1">
-                <a:solidFill>
-                  <a:srgbClr val="1B2236"/>
-                </a:solidFill>
-                <a:latin typeface="Lexend Deca" pitchFamily="34" charset="0"/>
-                <a:ea typeface="Lexend Deca" pitchFamily="34" charset="-122"/>
-                <a:cs typeface="Lexend Deca" pitchFamily="34" charset="-120"/>
-              </a:rPr>
-              <a:t>🤷</a:t>
-            </a:r>
-            <a:endParaRPr lang="en-US" sz="2200" dirty="0"/>
-          </a:p>
-        </p:txBody>
-      </p:sp>
-      <p:sp>
-        <p:nvSpPr>
-          <p:cNvPr id="41" name="Step 2"/>
-          <p:cNvSpPr/>
-          <p:nvPr/>
-        </p:nvSpPr>
-        <p:spPr>
-          <a:xfrm>
-            <a:off x="9235440" y="3017520"/>
-            <a:ext cx="2377440" cy="914400"/>
-          </a:xfrm>
-          <a:prstGeom prst="rect">
-            <a:avLst/>
-          </a:prstGeom>
-          <a:noFill/>
-          <a:ln w="38100">
-            <a:noFill/>
-          </a:ln>
-        </p:spPr>
-        <p:txBody>
-          <a:bodyPr wrap="square" lIns="73152" tIns="36576" rIns="73152" bIns="36576" rtlCol="0" anchor="ctr">
-            <a:noAutofit/>
-          </a:bodyPr>
-          <a:lstStyle/>
-          <a:p>
-            <a:pPr algn="l" indent="0" marL="0">
-              <a:buNone/>
-            </a:pPr>
-            <a:r>
-              <a:rPr lang="en-US" sz="2200" dirty="0">
-                <a:solidFill>
-                  <a:srgbClr val="1B2236"/>
-                </a:solidFill>
-                <a:latin typeface="Lexend Deca" pitchFamily="34" charset="0"/>
-                <a:ea typeface="Lexend Deca" pitchFamily="34" charset="-122"/>
-                <a:cs typeface="Lexend Deca" pitchFamily="34" charset="-120"/>
-              </a:rPr>
-              <a:t>I don't understand.</a:t>
-            </a:r>
-            <a:endParaRPr lang="en-US" sz="2200" dirty="0"/>
-          </a:p>
-        </p:txBody>
-      </p:sp>
-      <p:sp>
-        <p:nvSpPr>
-          <p:cNvPr id="42" name="Step num 3"/>
+          <p:cNvPr id="43" name="Step 3"/>
           <p:cNvSpPr/>
           <p:nvPr/>
         </p:nvSpPr>
         <p:spPr>
           <a:xfrm>
             <a:off x="8549640" y="4069080"/>
-            <a:ext cx="548640" cy="548640"/>
-          </a:xfrm>
-          <a:prstGeom prst="ellipse">
-            <a:avLst/>
-          </a:prstGeom>
-          <a:solidFill>
-            <a:srgbClr val="FFFFFF"/>
-          </a:solidFill>
-          <a:ln w="38100">
-            <a:noFill/>
-          </a:ln>
-        </p:spPr>
-        <p:txBody>
-          <a:bodyPr wrap="square" lIns="0" tIns="36576" rIns="0" bIns="36576" rtlCol="0" anchor="ctr">
-            <a:noAutofit/>
-          </a:bodyPr>
-          <a:lstStyle/>
-          <a:p>
-            <a:pPr algn="ctr" indent="0" marL="0">
-              <a:buNone/>
-            </a:pPr>
-            <a:r>
-              <a:rPr lang="en-US" sz="2200" dirty="0" b="1">
-                <a:solidFill>
-                  <a:srgbClr val="1B2236"/>
-                </a:solidFill>
-                <a:latin typeface="Lexend Deca" pitchFamily="34" charset="0"/>
-                <a:ea typeface="Lexend Deca" pitchFamily="34" charset="-122"/>
-                <a:cs typeface="Lexend Deca" pitchFamily="34" charset="-120"/>
-              </a:rPr>
-              <a:t>❓</a:t>
-            </a:r>
-            <a:endParaRPr lang="en-US" sz="2200" dirty="0"/>
-          </a:p>
-        </p:txBody>
-      </p:sp>
-      <p:sp>
-        <p:nvSpPr>
-          <p:cNvPr id="43" name="Step 3"/>
-          <p:cNvSpPr/>
-          <p:nvPr/>
-        </p:nvSpPr>
-        <p:spPr>
-          <a:xfrm>
-            <a:off x="9235440" y="4069080"/>
-            <a:ext cx="2377440" cy="914400"/>
+            <a:ext cx="3063240" cy="914400"/>
           </a:xfrm>
           <a:prstGeom prst="rect">
             <a:avLst/>
@@ -30550,7 +30023,7 @@
                 <a:ea typeface="Lexend Deca" pitchFamily="34" charset="-122"/>
                 <a:cs typeface="Lexend Deca" pitchFamily="34" charset="-120"/>
               </a:rPr>
-              <a:t>👂 ✅  Listen. Who is it?</a:t>
+              <a:t>Listen. Who is it?</a:t>
             </a:r>
             <a:endParaRPr lang="en-US" sz="2200" dirty="0"/>
           </a:p>
@@ -30570,7 +30043,7 @@
                 <a:ea typeface="Lexend Deca" pitchFamily="34" charset="-122"/>
                 <a:cs typeface="Lexend Deca" pitchFamily="34" charset="-120"/>
               </a:rPr>
-              <a:t>Ana or Carlos?</a:t>
+              <a:t>Check ✓ Ana or Carlos.</a:t>
             </a:r>
             <a:endParaRPr lang="en-US" sz="2200" dirty="0"/>
           </a:p>

</xml_diff>

<commit_message>
Remove decorative emoji from Level 1 Lesson 1, its deck, the Level 3 plan and the site UI; refresh exported content (#50, #42, #51)
</commit_message>
<xml_diff>
--- a/level1/slides/Level1_Lesson1_Slides.pptx
+++ b/level1/slides/Level1_Lesson1_Slides.pptx
@@ -4397,7 +4397,7 @@
                 <a:ea typeface="Lexend Deca" pitchFamily="34" charset="-122"/>
                 <a:cs typeface="Lexend Deca" pitchFamily="34" charset="-120"/>
               </a:rPr>
-              <a:t>👩 Ana</a:t>
+              <a:t>Ana</a:t>
             </a:r>
             <a:endParaRPr lang="en-US" sz="2200" dirty="0"/>
           </a:p>
@@ -4527,7 +4527,7 @@
                 <a:ea typeface="Lexend Deca" pitchFamily="34" charset="-122"/>
                 <a:cs typeface="Lexend Deca" pitchFamily="34" charset="-120"/>
               </a:rPr>
-              <a:t>👨 Carlos</a:t>
+              <a:t>Carlos</a:t>
             </a:r>
             <a:endParaRPr lang="en-US" sz="2200" dirty="0"/>
           </a:p>
@@ -6111,7 +6111,7 @@
                 <a:ea typeface="Lexend Deca" pitchFamily="34" charset="-122"/>
                 <a:cs typeface="Lexend Deca" pitchFamily="34" charset="-120"/>
               </a:rPr>
-              <a:t>👩 Ana:  __  __  __  __</a:t>
+              <a:t>Ana:  __  __  __  __</a:t>
             </a:r>
             <a:endParaRPr lang="en-US" sz="2000" dirty="0"/>
           </a:p>
@@ -6150,7 +6150,7 @@
                 <a:ea typeface="Lexend Deca" pitchFamily="34" charset="-122"/>
                 <a:cs typeface="Lexend Deca" pitchFamily="34" charset="-120"/>
               </a:rPr>
-              <a:t>👨 Carlos:  __  __  __  __</a:t>
+              <a:t>Carlos:  __  __  __  __</a:t>
             </a:r>
             <a:endParaRPr lang="en-US" sz="2000" dirty="0"/>
           </a:p>

</xml_diff>